<commit_message>
edit to pptx sprint 2
</commit_message>
<xml_diff>
--- a/team_review.pptx
+++ b/team_review.pptx
@@ -264,19 +264,19 @@
 <pc:chgInfo xmlns:a="http://schemas.openxmlformats.org/drawingml/2006/main" xmlns:r="http://schemas.openxmlformats.org/officeDocument/2006/relationships" xmlns:ac="http://schemas.microsoft.com/office/drawing/2013/main/command" xmlns:pc="http://schemas.microsoft.com/office/powerpoint/2013/main/command">
   <pc:docChgLst>
     <pc:chgData name="Corbin Wamsley" userId="b2e2ab5d7f51200e" providerId="LiveId" clId="{EECB8813-B7DA-47D8-9BD5-DA9F838D269A}"/>
-    <pc:docChg chg="modSld">
-      <pc:chgData name="Corbin Wamsley" userId="b2e2ab5d7f51200e" providerId="LiveId" clId="{EECB8813-B7DA-47D8-9BD5-DA9F838D269A}" dt="2026-09-30T05:36:58.572" v="296" actId="20577"/>
+    <pc:docChg chg="undo custSel modSld">
+      <pc:chgData name="Corbin Wamsley" userId="b2e2ab5d7f51200e" providerId="LiveId" clId="{EECB8813-B7DA-47D8-9BD5-DA9F838D269A}" dt="2026-10-14T16:28:00.499" v="1065" actId="20577"/>
       <pc:docMkLst>
         <pc:docMk/>
       </pc:docMkLst>
       <pc:sldChg chg="modSp mod">
-        <pc:chgData name="Corbin Wamsley" userId="b2e2ab5d7f51200e" providerId="LiveId" clId="{EECB8813-B7DA-47D8-9BD5-DA9F838D269A}" dt="2026-09-30T05:36:58.572" v="296" actId="20577"/>
+        <pc:chgData name="Corbin Wamsley" userId="b2e2ab5d7f51200e" providerId="LiveId" clId="{EECB8813-B7DA-47D8-9BD5-DA9F838D269A}" dt="2026-10-14T16:28:00.499" v="1065" actId="20577"/>
         <pc:sldMkLst>
           <pc:docMk/>
           <pc:sldMk cId="0" sldId="256"/>
         </pc:sldMkLst>
         <pc:graphicFrameChg chg="modGraphic">
-          <ac:chgData name="Corbin Wamsley" userId="b2e2ab5d7f51200e" providerId="LiveId" clId="{EECB8813-B7DA-47D8-9BD5-DA9F838D269A}" dt="2026-09-30T05:36:58.572" v="296" actId="20577"/>
+          <ac:chgData name="Corbin Wamsley" userId="b2e2ab5d7f51200e" providerId="LiveId" clId="{EECB8813-B7DA-47D8-9BD5-DA9F838D269A}" dt="2026-10-14T16:28:00.499" v="1065" actId="20577"/>
           <ac:graphicFrameMkLst>
             <pc:docMk/>
             <pc:sldMk cId="0" sldId="256"/>
@@ -5649,14 +5649,14 @@
           <p:nvPr>
             <p:extLst>
               <p:ext uri="{D42A27DB-BD31-4B8C-83A1-F6EECF244321}">
-                <p14:modId xmlns:p14="http://schemas.microsoft.com/office/powerpoint/2010/main" val="2951665426"/>
+                <p14:modId xmlns:p14="http://schemas.microsoft.com/office/powerpoint/2010/main" val="3875278843"/>
               </p:ext>
             </p:extLst>
           </p:nvPr>
         </p:nvGraphicFramePr>
         <p:xfrm>
           <a:off x="453482" y="1249375"/>
-          <a:ext cx="8162694" cy="3657540"/>
+          <a:ext cx="8162694" cy="3474660"/>
         </p:xfrm>
         <a:graphic>
           <a:graphicData uri="http://schemas.openxmlformats.org/drawingml/2006/table">
@@ -5726,7 +5726,7 @@
                       </a:pPr>
                       <a:r>
                         <a:rPr lang="en" sz="1200" dirty="0"/>
-                        <a:t>Sprint: 1</a:t>
+                        <a:t>Sprint: 2</a:t>
                       </a:r>
                       <a:endParaRPr sz="1200" dirty="0"/>
                     </a:p>
@@ -5757,7 +5757,7 @@
                       </a:pPr>
                       <a:r>
                         <a:rPr lang="en" sz="1200" dirty="0"/>
-                        <a:t>Team Members: Corbin, Ryan, David</a:t>
+                        <a:t>Team Members: Corbin, Ryan, David, Jay</a:t>
                       </a:r>
                       <a:endParaRPr sz="1200" dirty="0"/>
                     </a:p>
@@ -5849,7 +5849,7 @@
                         </a:spcAft>
                         <a:buNone/>
                       </a:pPr>
-                      <a:endParaRPr sz="1200" b="1" u="sng" dirty="0"/>
+                      <a:endParaRPr lang="en-US" sz="1200" b="1" u="sng" dirty="0"/>
                     </a:p>
                     <a:p>
                       <a:pPr marL="457200" lvl="0" indent="-317500" algn="l" rtl="0">
@@ -5863,10 +5863,9 @@
                         <a:buChar char="●"/>
                       </a:pPr>
                       <a:r>
-                        <a:rPr lang="en" sz="1200" dirty="0"/>
-                        <a:t>Drafted project plan and scope for the activities web app</a:t>
+                        <a:rPr lang="en-US" sz="1200" dirty="0"/>
+                        <a:t>Finished activity post routes</a:t>
                       </a:r>
-                      <a:endParaRPr sz="1200" dirty="0"/>
                     </a:p>
                     <a:p>
                       <a:pPr marL="457200" lvl="0" indent="-317500" algn="l" rtl="0">
@@ -5880,10 +5879,9 @@
                         <a:buChar char="●"/>
                       </a:pPr>
                       <a:r>
-                        <a:rPr lang="en" sz="1200" dirty="0"/>
-                        <a:t>Scaffolded the Express app (app.js, server.js, routes/controllers/models)</a:t>
+                        <a:rPr lang="en-US" sz="1200" dirty="0"/>
+                        <a:t>Finished MVP and backend</a:t>
                       </a:r>
-                      <a:endParaRPr sz="1200" dirty="0"/>
                     </a:p>
                     <a:p>
                       <a:pPr marL="457200" lvl="0" indent="-317500" algn="l" rtl="0">
@@ -5897,10 +5895,9 @@
                         <a:buChar char="●"/>
                       </a:pPr>
                       <a:r>
-                        <a:rPr lang="en" sz="1200" dirty="0"/>
-                        <a:t>Set up dev tooling: ESLint, Prettier, Jest/Supertest, nodemon</a:t>
+                        <a:rPr lang="en-US" sz="1200" dirty="0"/>
+                        <a:t>Finished Authentication</a:t>
                       </a:r>
-                      <a:endParaRPr sz="1200" dirty="0"/>
                     </a:p>
                     <a:p>
                       <a:pPr marL="457200" lvl="0" indent="-317500" algn="l" rtl="0">
@@ -5914,10 +5911,14 @@
                         <a:buChar char="●"/>
                       </a:pPr>
                       <a:r>
-                        <a:rPr lang="en" sz="1200" dirty="0"/>
-                        <a:t>Configured environment/git setup and pushed initial scaffold to GitHub</a:t>
+                        <a:rPr lang="en-US" sz="1200" dirty="0"/>
+                        <a:t>Fixed CRUD </a:t>
                       </a:r>
-                      <a:endParaRPr sz="1200" dirty="0"/>
+                      <a:r>
+                        <a:rPr lang="en-US" sz="1200"/>
+                        <a:t>api</a:t>
+                      </a:r>
+                      <a:endParaRPr lang="en-US" sz="1200" dirty="0"/>
                     </a:p>
                   </a:txBody>
                   <a:tcPr marL="91425" marR="91425" marT="91425" marB="91425"/>
@@ -5993,41 +5994,8 @@
                             <a:schemeClr val="dk1"/>
                           </a:solidFill>
                         </a:rPr>
-                        <a:t>Flushing out framework backbone</a:t>
+                        <a:t>Finishing the commenting routes</a:t>
                       </a:r>
-                      <a:endParaRPr sz="1200" dirty="0">
-                        <a:solidFill>
-                          <a:schemeClr val="dk1"/>
-                        </a:solidFill>
-                      </a:endParaRPr>
-                    </a:p>
-                    <a:p>
-                      <a:pPr marL="457200" lvl="0" indent="-317500" algn="l" rtl="0">
-                        <a:spcBef>
-                          <a:spcPts val="0"/>
-                        </a:spcBef>
-                        <a:spcAft>
-                          <a:spcPts val="0"/>
-                        </a:spcAft>
-                        <a:buClr>
-                          <a:schemeClr val="dk1"/>
-                        </a:buClr>
-                        <a:buSzPts val="1400"/>
-                        <a:buChar char="●"/>
-                      </a:pPr>
-                      <a:r>
-                        <a:rPr lang="en" sz="1200" dirty="0">
-                          <a:solidFill>
-                            <a:schemeClr val="dk1"/>
-                          </a:solidFill>
-                        </a:rPr>
-                        <a:t>Hardening authentication</a:t>
-                      </a:r>
-                      <a:endParaRPr sz="1200" dirty="0">
-                        <a:solidFill>
-                          <a:schemeClr val="dk1"/>
-                        </a:solidFill>
-                      </a:endParaRPr>
                     </a:p>
                     <a:p>
                       <a:pPr marL="457200" lvl="0" indent="-317500" algn="l" rtl="0">
@@ -6049,13 +6017,24 @@
                             <a:schemeClr val="dk1"/>
                           </a:solidFill>
                         </a:rPr>
-                        <a:t>UI placeholder</a:t>
+                        <a:t>Finishing up </a:t>
                       </a:r>
-                      <a:endParaRPr sz="1200" dirty="0">
-                        <a:solidFill>
-                          <a:schemeClr val="dk1"/>
-                        </a:solidFill>
-                      </a:endParaRPr>
+                      <a:r>
+                        <a:rPr lang="en-US" sz="1200" dirty="0" err="1">
+                          <a:solidFill>
+                            <a:schemeClr val="dk1"/>
+                          </a:solidFill>
+                        </a:rPr>
+                        <a:t>api</a:t>
+                      </a:r>
+                      <a:r>
+                        <a:rPr lang="en-US" sz="1200" dirty="0">
+                          <a:solidFill>
+                            <a:schemeClr val="dk1"/>
+                          </a:solidFill>
+                        </a:rPr>
+                        <a:t> calls for Google Maps</a:t>
+                      </a:r>
                     </a:p>
                     <a:p>
                       <a:pPr marL="457200" lvl="0" indent="-317500" algn="l" rtl="0">
@@ -6072,20 +6051,12 @@
                         <a:buChar char="●"/>
                       </a:pPr>
                       <a:r>
-                        <a:rPr lang="en" sz="1200" dirty="0">
+                        <a:rPr lang="en-US" sz="1200" dirty="0">
                           <a:solidFill>
                             <a:schemeClr val="dk1"/>
                           </a:solidFill>
                         </a:rPr>
-                        <a:t>Finalizing </a:t>
-                      </a:r>
-                      <a:r>
-                        <a:rPr lang="en" sz="1200">
-                          <a:solidFill>
-                            <a:schemeClr val="dk1"/>
-                          </a:solidFill>
-                        </a:rPr>
-                        <a:t>database schema</a:t>
+                        <a:t>Finishing UI and frontend</a:t>
                       </a:r>
                       <a:endParaRPr lang="en" sz="1200" dirty="0">
                         <a:solidFill>
@@ -6181,24 +6152,7 @@
                       </a:pPr>
                       <a:r>
                         <a:rPr lang="en-US" sz="1200" dirty="0"/>
-                        <a:t>Map integration/ google maps API</a:t>
-                      </a:r>
-                      <a:endParaRPr sz="1200" dirty="0"/>
-                    </a:p>
-                    <a:p>
-                      <a:pPr marL="457200" lvl="0" indent="-317500" algn="l" rtl="0">
-                        <a:spcBef>
-                          <a:spcPts val="0"/>
-                        </a:spcBef>
-                        <a:spcAft>
-                          <a:spcPts val="0"/>
-                        </a:spcAft>
-                        <a:buSzPts val="1400"/>
-                        <a:buChar char="●"/>
-                      </a:pPr>
-                      <a:r>
-                        <a:rPr lang="en" sz="1200" dirty="0"/>
-                        <a:t>Event creation\</a:t>
+                        <a:t>Filter activities from the feed</a:t>
                       </a:r>
                     </a:p>
                     <a:p>
@@ -6213,10 +6167,9 @@
                         <a:buChar char="●"/>
                       </a:pPr>
                       <a:r>
-                        <a:rPr lang="en" sz="1200" dirty="0"/>
-                        <a:t>User account creation</a:t>
+                        <a:rPr lang="en-US" sz="1200" dirty="0"/>
+                        <a:t>Update activity UI</a:t>
                       </a:r>
-                      <a:endParaRPr sz="1200" dirty="0"/>
                     </a:p>
                     <a:p>
                       <a:pPr marL="457200" lvl="0" indent="-317500" algn="l" rtl="0">
@@ -6230,8 +6183,8 @@
                         <a:buChar char="●"/>
                       </a:pPr>
                       <a:r>
-                        <a:rPr lang="en" sz="1200" dirty="0"/>
-                        <a:t>Threads</a:t>
+                        <a:rPr lang="en-US" sz="1200" dirty="0"/>
+                        <a:t>Finish commenting routes</a:t>
                       </a:r>
                       <a:endParaRPr sz="1200" dirty="0"/>
                     </a:p>

</xml_diff>